<commit_message>
remove old assignment data, add resit
</commit_message>
<xml_diff>
--- a/msmr_readings/images_lmm/un_lmm.pptx
+++ b/msmr_readings/images_lmm/un_lmm.pptx
@@ -262,7 +262,7 @@
           <a:p>
             <a:fld id="{1F0CBD5E-49E7-7C4F-9044-BAEC7178F380}" type="datetimeFigureOut">
               <a:rPr lang="en-US" smtClean="0"/>
-              <a:t>2/6/2024</a:t>
+              <a:t>4/1/2026</a:t>
             </a:fld>
             <a:endParaRPr lang="en-US"/>
           </a:p>
@@ -462,7 +462,7 @@
           <a:p>
             <a:fld id="{1F0CBD5E-49E7-7C4F-9044-BAEC7178F380}" type="datetimeFigureOut">
               <a:rPr lang="en-US" smtClean="0"/>
-              <a:t>2/6/2024</a:t>
+              <a:t>4/1/2026</a:t>
             </a:fld>
             <a:endParaRPr lang="en-US"/>
           </a:p>
@@ -672,7 +672,7 @@
           <a:p>
             <a:fld id="{1F0CBD5E-49E7-7C4F-9044-BAEC7178F380}" type="datetimeFigureOut">
               <a:rPr lang="en-US" smtClean="0"/>
-              <a:t>2/6/2024</a:t>
+              <a:t>4/1/2026</a:t>
             </a:fld>
             <a:endParaRPr lang="en-US"/>
           </a:p>
@@ -872,7 +872,7 @@
           <a:p>
             <a:fld id="{1F0CBD5E-49E7-7C4F-9044-BAEC7178F380}" type="datetimeFigureOut">
               <a:rPr lang="en-US" smtClean="0"/>
-              <a:t>2/6/2024</a:t>
+              <a:t>4/1/2026</a:t>
             </a:fld>
             <a:endParaRPr lang="en-US"/>
           </a:p>
@@ -1148,7 +1148,7 @@
           <a:p>
             <a:fld id="{1F0CBD5E-49E7-7C4F-9044-BAEC7178F380}" type="datetimeFigureOut">
               <a:rPr lang="en-US" smtClean="0"/>
-              <a:t>2/6/2024</a:t>
+              <a:t>4/1/2026</a:t>
             </a:fld>
             <a:endParaRPr lang="en-US"/>
           </a:p>
@@ -1416,7 +1416,7 @@
           <a:p>
             <a:fld id="{1F0CBD5E-49E7-7C4F-9044-BAEC7178F380}" type="datetimeFigureOut">
               <a:rPr lang="en-US" smtClean="0"/>
-              <a:t>2/6/2024</a:t>
+              <a:t>4/1/2026</a:t>
             </a:fld>
             <a:endParaRPr lang="en-US"/>
           </a:p>
@@ -1831,7 +1831,7 @@
           <a:p>
             <a:fld id="{1F0CBD5E-49E7-7C4F-9044-BAEC7178F380}" type="datetimeFigureOut">
               <a:rPr lang="en-US" smtClean="0"/>
-              <a:t>2/6/2024</a:t>
+              <a:t>4/1/2026</a:t>
             </a:fld>
             <a:endParaRPr lang="en-US"/>
           </a:p>
@@ -1973,7 +1973,7 @@
           <a:p>
             <a:fld id="{1F0CBD5E-49E7-7C4F-9044-BAEC7178F380}" type="datetimeFigureOut">
               <a:rPr lang="en-US" smtClean="0"/>
-              <a:t>2/6/2024</a:t>
+              <a:t>4/1/2026</a:t>
             </a:fld>
             <a:endParaRPr lang="en-US"/>
           </a:p>
@@ -2086,7 +2086,7 @@
           <a:p>
             <a:fld id="{1F0CBD5E-49E7-7C4F-9044-BAEC7178F380}" type="datetimeFigureOut">
               <a:rPr lang="en-US" smtClean="0"/>
-              <a:t>2/6/2024</a:t>
+              <a:t>4/1/2026</a:t>
             </a:fld>
             <a:endParaRPr lang="en-US"/>
           </a:p>
@@ -2399,7 +2399,7 @@
           <a:p>
             <a:fld id="{1F0CBD5E-49E7-7C4F-9044-BAEC7178F380}" type="datetimeFigureOut">
               <a:rPr lang="en-US" smtClean="0"/>
-              <a:t>2/6/2024</a:t>
+              <a:t>4/1/2026</a:t>
             </a:fld>
             <a:endParaRPr lang="en-US"/>
           </a:p>
@@ -2688,7 +2688,7 @@
           <a:p>
             <a:fld id="{1F0CBD5E-49E7-7C4F-9044-BAEC7178F380}" type="datetimeFigureOut">
               <a:rPr lang="en-US" smtClean="0"/>
-              <a:t>2/6/2024</a:t>
+              <a:t>4/1/2026</a:t>
             </a:fld>
             <a:endParaRPr lang="en-US"/>
           </a:p>
@@ -2931,7 +2931,7 @@
           <a:p>
             <a:fld id="{1F0CBD5E-49E7-7C4F-9044-BAEC7178F380}" type="datetimeFigureOut">
               <a:rPr lang="en-US" smtClean="0"/>
-              <a:t>2/6/2024</a:t>
+              <a:t>4/1/2026</a:t>
             </a:fld>
             <a:endParaRPr lang="en-US"/>
           </a:p>
@@ -6084,6 +6084,149 @@
           <a:chExt cx="0" cy="0"/>
         </a:xfrm>
       </p:grpSpPr>
+      <mc:AlternateContent xmlns:mc="http://schemas.openxmlformats.org/markup-compatibility/2006">
+        <mc:Choice xmlns:a14="http://schemas.microsoft.com/office/drawing/2010/main" Requires="a14">
+          <p:sp>
+            <p:nvSpPr>
+              <p:cNvPr id="41" name="TextBox 40">
+                <a:extLst>
+                  <a:ext uri="{FF2B5EF4-FFF2-40B4-BE49-F238E27FC236}">
+                    <a16:creationId xmlns:a16="http://schemas.microsoft.com/office/drawing/2014/main" id="{B90E33FC-528F-FA49-A3FB-EE70D74C8BD9}"/>
+                  </a:ext>
+                </a:extLst>
+              </p:cNvPr>
+              <p:cNvSpPr txBox="1"/>
+              <p:nvPr/>
+            </p:nvSpPr>
+            <p:spPr>
+              <a:xfrm>
+                <a:off x="6592465" y="2172702"/>
+                <a:ext cx="537711" cy="369332"/>
+              </a:xfrm>
+              <a:prstGeom prst="rect">
+                <a:avLst/>
+              </a:prstGeom>
+              <a:noFill/>
+              <a:ln>
+                <a:noFill/>
+              </a:ln>
+            </p:spPr>
+            <p:txBody>
+              <a:bodyPr wrap="none" rtlCol="0">
+                <a:spAutoFit/>
+              </a:bodyPr>
+              <a:lstStyle/>
+              <a:p>
+                <a:pPr/>
+                <a14:m>
+                  <m:oMathPara xmlns:m="http://schemas.openxmlformats.org/officeDocument/2006/math">
+                    <m:oMathParaPr>
+                      <m:jc m:val="centerGroup"/>
+                    </m:oMathParaPr>
+                    <m:oMath xmlns:m="http://schemas.openxmlformats.org/officeDocument/2006/math">
+                      <m:sSub>
+                        <m:sSubPr>
+                          <m:ctrlPr>
+                            <a:rPr lang="en-US" b="0" i="1" smtClean="0">
+                              <a:solidFill>
+                                <a:srgbClr val="FFC000"/>
+                              </a:solidFill>
+                              <a:latin typeface="Cambria Math" panose="02040503050406030204" pitchFamily="18" charset="0"/>
+                            </a:rPr>
+                          </m:ctrlPr>
+                        </m:sSubPr>
+                        <m:e>
+                          <m:r>
+                            <a:rPr lang="en-GB" b="0" i="1" smtClean="0">
+                              <a:solidFill>
+                                <a:srgbClr val="FFC000"/>
+                              </a:solidFill>
+                              <a:latin typeface="Cambria Math" panose="02040503050406030204" pitchFamily="18" charset="0"/>
+                            </a:rPr>
+                            <m:t>𝑢</m:t>
+                          </m:r>
+                        </m:e>
+                        <m:sub>
+                          <m:r>
+                            <a:rPr lang="en-US" b="0" i="1" smtClean="0">
+                              <a:solidFill>
+                                <a:srgbClr val="FFC000"/>
+                              </a:solidFill>
+                              <a:latin typeface="Cambria Math" panose="02040503050406030204" pitchFamily="18" charset="0"/>
+                            </a:rPr>
+                            <m:t>1</m:t>
+                          </m:r>
+                          <m:r>
+                            <a:rPr lang="en-US" b="0" i="1" smtClean="0">
+                              <a:solidFill>
+                                <a:srgbClr val="FFC000"/>
+                              </a:solidFill>
+                              <a:latin typeface="Cambria Math" panose="02040503050406030204" pitchFamily="18" charset="0"/>
+                            </a:rPr>
+                            <m:t>𝑖</m:t>
+                          </m:r>
+                        </m:sub>
+                      </m:sSub>
+                    </m:oMath>
+                  </m:oMathPara>
+                </a14:m>
+                <a:endParaRPr lang="en-US" dirty="0">
+                  <a:solidFill>
+                    <a:srgbClr val="FFC000"/>
+                  </a:solidFill>
+                </a:endParaRPr>
+              </a:p>
+            </p:txBody>
+          </p:sp>
+        </mc:Choice>
+        <mc:Fallback>
+          <p:sp>
+            <p:nvSpPr>
+              <p:cNvPr id="41" name="TextBox 40">
+                <a:extLst>
+                  <a:ext uri="{FF2B5EF4-FFF2-40B4-BE49-F238E27FC236}">
+                    <a16:creationId xmlns:a16="http://schemas.microsoft.com/office/drawing/2014/main" id="{B90E33FC-528F-FA49-A3FB-EE70D74C8BD9}"/>
+                  </a:ext>
+                </a:extLst>
+              </p:cNvPr>
+              <p:cNvSpPr txBox="1">
+                <a:spLocks noRot="1" noChangeAspect="1" noMove="1" noResize="1" noEditPoints="1" noAdjustHandles="1" noChangeArrowheads="1" noChangeShapeType="1" noTextEdit="1"/>
+              </p:cNvSpPr>
+              <p:nvPr/>
+            </p:nvSpPr>
+            <p:spPr>
+              <a:xfrm>
+                <a:off x="6592465" y="2172702"/>
+                <a:ext cx="537711" cy="369332"/>
+              </a:xfrm>
+              <a:prstGeom prst="rect">
+                <a:avLst/>
+              </a:prstGeom>
+              <a:blipFill>
+                <a:blip r:embed="rId2"/>
+                <a:stretch>
+                  <a:fillRect/>
+                </a:stretch>
+              </a:blipFill>
+              <a:ln>
+                <a:noFill/>
+              </a:ln>
+            </p:spPr>
+            <p:txBody>
+              <a:bodyPr/>
+              <a:lstStyle/>
+              <a:p>
+                <a:r>
+                  <a:rPr lang="en-GB">
+                    <a:noFill/>
+                  </a:rPr>
+                  <a:t> </a:t>
+                </a:r>
+              </a:p>
+            </p:txBody>
+          </p:sp>
+        </mc:Fallback>
+      </mc:AlternateContent>
       <p:cxnSp>
         <p:nvCxnSpPr>
           <p:cNvPr id="40" name="Straight Connector 39">
@@ -6400,15 +6543,11 @@
             <a:avLst/>
           </a:prstGeom>
           <a:solidFill>
-            <a:schemeClr val="accent6">
-              <a:lumMod val="75000"/>
-            </a:schemeClr>
+            <a:srgbClr val="FF0000"/>
           </a:solidFill>
           <a:ln>
             <a:solidFill>
-              <a:schemeClr val="accent6">
-                <a:lumMod val="75000"/>
-              </a:schemeClr>
+              <a:srgbClr val="FF0000"/>
             </a:solidFill>
           </a:ln>
         </p:spPr>
@@ -6458,15 +6597,11 @@
             <a:avLst/>
           </a:prstGeom>
           <a:solidFill>
-            <a:schemeClr val="accent6">
-              <a:lumMod val="75000"/>
-            </a:schemeClr>
+            <a:srgbClr val="FF0000"/>
           </a:solidFill>
           <a:ln>
             <a:solidFill>
-              <a:schemeClr val="accent6">
-                <a:lumMod val="75000"/>
-              </a:schemeClr>
+              <a:srgbClr val="FF0000"/>
             </a:solidFill>
           </a:ln>
         </p:spPr>
@@ -6509,22 +6644,18 @@
         </p:nvSpPr>
         <p:spPr>
           <a:xfrm>
-            <a:off x="6975067" y="2148989"/>
+            <a:off x="7441228" y="2083250"/>
             <a:ext cx="105104" cy="105104"/>
           </a:xfrm>
           <a:prstGeom prst="ellipse">
             <a:avLst/>
           </a:prstGeom>
           <a:solidFill>
-            <a:schemeClr val="accent6">
-              <a:lumMod val="75000"/>
-            </a:schemeClr>
+            <a:srgbClr val="FF0000"/>
           </a:solidFill>
           <a:ln>
             <a:solidFill>
-              <a:schemeClr val="accent6">
-                <a:lumMod val="75000"/>
-              </a:schemeClr>
+              <a:srgbClr val="FF0000"/>
             </a:solidFill>
           </a:ln>
         </p:spPr>
@@ -6574,15 +6705,11 @@
             <a:avLst/>
           </a:prstGeom>
           <a:solidFill>
-            <a:schemeClr val="accent6">
-              <a:lumMod val="75000"/>
-            </a:schemeClr>
+            <a:srgbClr val="FF0000"/>
           </a:solidFill>
           <a:ln>
             <a:solidFill>
-              <a:schemeClr val="accent6">
-                <a:lumMod val="75000"/>
-              </a:schemeClr>
+              <a:srgbClr val="FF0000"/>
             </a:solidFill>
           </a:ln>
         </p:spPr>
@@ -6635,9 +6762,7 @@
           </a:prstGeom>
           <a:ln w="28575">
             <a:solidFill>
-              <a:schemeClr val="accent6">
-                <a:lumMod val="75000"/>
-              </a:schemeClr>
+              <a:srgbClr val="00B050"/>
             </a:solidFill>
           </a:ln>
         </p:spPr>
@@ -6672,15 +6797,15 @@
         </p:nvCxnSpPr>
         <p:spPr>
           <a:xfrm flipV="1">
-            <a:off x="2108744" y="3164164"/>
-            <a:ext cx="8391090" cy="1770444"/>
+            <a:off x="2492372" y="3164165"/>
+            <a:ext cx="8007462" cy="1680577"/>
           </a:xfrm>
           <a:prstGeom prst="line">
             <a:avLst/>
           </a:prstGeom>
           <a:ln w="28575">
             <a:solidFill>
-              <a:schemeClr val="accent1"/>
+              <a:srgbClr val="4909FF"/>
             </a:solidFill>
           </a:ln>
         </p:spPr>
@@ -6713,7 +6838,7 @@
         </p:nvSpPr>
         <p:spPr>
           <a:xfrm>
-            <a:off x="10567059" y="2915175"/>
+            <a:off x="10452690" y="2961568"/>
             <a:ext cx="1242071" cy="369332"/>
           </a:xfrm>
           <a:prstGeom prst="rect">
@@ -6730,7 +6855,7 @@
             <a:r>
               <a:rPr lang="en-US" dirty="0">
                 <a:solidFill>
-                  <a:schemeClr val="accent1"/>
+                  <a:srgbClr val="4909FF"/>
                 </a:solidFill>
               </a:rPr>
               <a:t>overall line</a:t>
@@ -6754,8 +6879,8 @@
             </p:nvSpPr>
             <p:spPr>
               <a:xfrm>
-                <a:off x="2853701" y="4749942"/>
-                <a:ext cx="556819" cy="369332"/>
+                <a:off x="1732664" y="4663777"/>
+                <a:ext cx="462626" cy="369332"/>
               </a:xfrm>
               <a:prstGeom prst="rect">
                 <a:avLst/>
@@ -6780,7 +6905,7 @@
                           <m:ctrlPr>
                             <a:rPr lang="en-US" b="0" i="1" smtClean="0">
                               <a:solidFill>
-                                <a:schemeClr val="accent1"/>
+                                <a:srgbClr val="4909FF"/>
                               </a:solidFill>
                               <a:latin typeface="Cambria Math" panose="02040503050406030204" pitchFamily="18" charset="0"/>
                             </a:rPr>
@@ -6788,24 +6913,24 @@
                         </m:sSubPr>
                         <m:e>
                           <m:r>
-                            <a:rPr lang="en-US" b="0" i="1" smtClean="0">
+                            <a:rPr lang="en-GB" b="0" i="1" smtClean="0">
                               <a:solidFill>
-                                <a:schemeClr val="accent1"/>
+                                <a:srgbClr val="4909FF"/>
                               </a:solidFill>
                               <a:latin typeface="Cambria Math" panose="02040503050406030204" pitchFamily="18" charset="0"/>
                             </a:rPr>
-                            <m:t>𝛾</m:t>
+                            <m:t>𝑏</m:t>
                           </m:r>
                         </m:e>
                         <m:sub>
                           <m:r>
                             <a:rPr lang="en-US" b="0" i="1" smtClean="0">
                               <a:solidFill>
-                                <a:schemeClr val="accent1"/>
+                                <a:srgbClr val="4909FF"/>
                               </a:solidFill>
                               <a:latin typeface="Cambria Math" panose="02040503050406030204" pitchFamily="18" charset="0"/>
                             </a:rPr>
-                            <m:t>00</m:t>
+                            <m:t>0</m:t>
                           </m:r>
                         </m:sub>
                       </m:sSub>
@@ -6814,7 +6939,7 @@
                 </a14:m>
                 <a:endParaRPr lang="en-US" dirty="0">
                   <a:solidFill>
-                    <a:schemeClr val="accent1"/>
+                    <a:srgbClr val="4909FF"/>
                   </a:solidFill>
                 </a:endParaRPr>
               </a:p>
@@ -6838,16 +6963,16 @@
             </p:nvSpPr>
             <p:spPr>
               <a:xfrm>
-                <a:off x="2853701" y="4749942"/>
-                <a:ext cx="556819" cy="369332"/>
+                <a:off x="1732664" y="4663777"/>
+                <a:ext cx="462626" cy="369332"/>
               </a:xfrm>
               <a:prstGeom prst="rect">
                 <a:avLst/>
               </a:prstGeom>
               <a:blipFill>
-                <a:blip r:embed="rId2"/>
+                <a:blip r:embed="rId3"/>
                 <a:stretch>
-                  <a:fillRect b="-3279"/>
+                  <a:fillRect/>
                 </a:stretch>
               </a:blipFill>
             </p:spPr>
@@ -6882,8 +7007,8 @@
             </p:nvSpPr>
             <p:spPr>
               <a:xfrm>
-                <a:off x="7614090" y="3719375"/>
-                <a:ext cx="551498" cy="369332"/>
+                <a:off x="6639927" y="3904646"/>
+                <a:ext cx="457305" cy="369332"/>
               </a:xfrm>
               <a:prstGeom prst="rect">
                 <a:avLst/>
@@ -6911,7 +7036,7 @@
                           <m:ctrlPr>
                             <a:rPr lang="en-US" b="0" i="1" smtClean="0">
                               <a:solidFill>
-                                <a:schemeClr val="accent1"/>
+                                <a:srgbClr val="4909FF"/>
                               </a:solidFill>
                               <a:latin typeface="Cambria Math" panose="02040503050406030204" pitchFamily="18" charset="0"/>
                             </a:rPr>
@@ -6919,24 +7044,24 @@
                         </m:sSubPr>
                         <m:e>
                           <m:r>
-                            <a:rPr lang="en-US" b="0" i="1" smtClean="0">
+                            <a:rPr lang="en-GB" b="0" i="1" smtClean="0">
                               <a:solidFill>
-                                <a:schemeClr val="accent1"/>
+                                <a:srgbClr val="4909FF"/>
                               </a:solidFill>
                               <a:latin typeface="Cambria Math" panose="02040503050406030204" pitchFamily="18" charset="0"/>
                             </a:rPr>
-                            <m:t>𝛾</m:t>
+                            <m:t>𝑏</m:t>
                           </m:r>
                         </m:e>
                         <m:sub>
                           <m:r>
                             <a:rPr lang="en-US" b="0" i="1" smtClean="0">
                               <a:solidFill>
-                                <a:schemeClr val="accent1"/>
+                                <a:srgbClr val="4909FF"/>
                               </a:solidFill>
                               <a:latin typeface="Cambria Math" panose="02040503050406030204" pitchFamily="18" charset="0"/>
                             </a:rPr>
-                            <m:t>10</m:t>
+                            <m:t>1</m:t>
                           </m:r>
                         </m:sub>
                       </m:sSub>
@@ -6945,7 +7070,7 @@
                 </a14:m>
                 <a:endParaRPr lang="en-US" dirty="0">
                   <a:solidFill>
-                    <a:schemeClr val="accent1"/>
+                    <a:srgbClr val="4909FF"/>
                   </a:solidFill>
                 </a:endParaRPr>
               </a:p>
@@ -6969,16 +7094,16 @@
             </p:nvSpPr>
             <p:spPr>
               <a:xfrm>
-                <a:off x="7614090" y="3719375"/>
-                <a:ext cx="551498" cy="369332"/>
+                <a:off x="6639927" y="3904646"/>
+                <a:ext cx="457305" cy="369332"/>
               </a:xfrm>
               <a:prstGeom prst="rect">
                 <a:avLst/>
               </a:prstGeom>
               <a:blipFill>
-                <a:blip r:embed="rId3"/>
+                <a:blip r:embed="rId4"/>
                 <a:stretch>
-                  <a:fillRect b="-3279"/>
+                  <a:fillRect/>
                 </a:stretch>
               </a:blipFill>
               <a:ln>
@@ -7014,17 +7139,17 @@
         </p:nvCxnSpPr>
         <p:spPr>
           <a:xfrm>
-            <a:off x="6304289" y="4071417"/>
+            <a:off x="5330126" y="4256688"/>
             <a:ext cx="1236883" cy="0"/>
           </a:xfrm>
           <a:prstGeom prst="line">
             <a:avLst/>
           </a:prstGeom>
-          <a:ln w="38100">
+          <a:ln w="19050">
             <a:solidFill>
-              <a:schemeClr val="accent1"/>
+              <a:srgbClr val="4909FF"/>
             </a:solidFill>
-            <a:prstDash val="solid"/>
+            <a:prstDash val="sysDash"/>
           </a:ln>
         </p:spPr>
         <p:style>
@@ -7058,7 +7183,7 @@
         </p:nvCxnSpPr>
         <p:spPr>
           <a:xfrm>
-            <a:off x="7551683" y="3797043"/>
+            <a:off x="6577520" y="3982314"/>
             <a:ext cx="0" cy="284516"/>
           </a:xfrm>
           <a:prstGeom prst="line">
@@ -7066,7 +7191,7 @@
           </a:prstGeom>
           <a:ln w="38100">
             <a:solidFill>
-              <a:schemeClr val="accent1"/>
+              <a:srgbClr val="4909FF"/>
             </a:solidFill>
             <a:prstDash val="solid"/>
           </a:ln>
@@ -7102,7 +7227,7 @@
             </p:nvSpPr>
             <p:spPr>
               <a:xfrm>
-                <a:off x="6745128" y="4058700"/>
+                <a:off x="5770965" y="4243971"/>
                 <a:ext cx="365805" cy="369332"/>
               </a:xfrm>
               <a:prstGeom prst="rect">
@@ -7129,7 +7254,7 @@
                       <m:r>
                         <a:rPr lang="en-US" b="0" i="1" smtClean="0">
                           <a:solidFill>
-                            <a:schemeClr val="accent1"/>
+                            <a:srgbClr val="4909FF"/>
                           </a:solidFill>
                           <a:latin typeface="Cambria Math" panose="02040503050406030204" pitchFamily="18" charset="0"/>
                         </a:rPr>
@@ -7140,7 +7265,7 @@
                 </a14:m>
                 <a:endParaRPr lang="en-US" dirty="0">
                   <a:solidFill>
-                    <a:schemeClr val="accent1"/>
+                    <a:srgbClr val="4909FF"/>
                   </a:solidFill>
                 </a:endParaRPr>
               </a:p>
@@ -7164,14 +7289,14 @@
             </p:nvSpPr>
             <p:spPr>
               <a:xfrm>
-                <a:off x="6745128" y="4058700"/>
+                <a:off x="5770965" y="4243971"/>
                 <a:ext cx="365805" cy="369332"/>
               </a:xfrm>
               <a:prstGeom prst="rect">
                 <a:avLst/>
               </a:prstGeom>
               <a:blipFill>
-                <a:blip r:embed="rId4"/>
+                <a:blip r:embed="rId5"/>
                 <a:stretch>
                   <a:fillRect/>
                 </a:stretch>
@@ -7211,8 +7336,8 @@
             </p:nvSpPr>
             <p:spPr>
               <a:xfrm>
-                <a:off x="1130432" y="3370459"/>
-                <a:ext cx="1692386" cy="369332"/>
+                <a:off x="1302921" y="3661386"/>
+                <a:ext cx="1236172" cy="369332"/>
               </a:xfrm>
               <a:prstGeom prst="rect">
                 <a:avLst/>
@@ -7232,12 +7357,21 @@
                       <m:jc m:val="centerGroup"/>
                     </m:oMathParaPr>
                     <m:oMath xmlns:m="http://schemas.openxmlformats.org/officeDocument/2006/math">
+                      <m:r>
+                        <a:rPr lang="en-GB" b="0" i="1" smtClean="0">
+                          <a:solidFill>
+                            <a:srgbClr val="00B050"/>
+                          </a:solidFill>
+                          <a:latin typeface="Cambria Math" panose="02040503050406030204" pitchFamily="18" charset="0"/>
+                        </a:rPr>
+                        <m:t>(</m:t>
+                      </m:r>
                       <m:sSub>
                         <m:sSubPr>
                           <m:ctrlPr>
                             <a:rPr lang="en-US" b="0" i="1" smtClean="0">
                               <a:solidFill>
-                                <a:schemeClr val="accent1"/>
+                                <a:srgbClr val="4909FF"/>
                               </a:solidFill>
                               <a:latin typeface="Cambria Math" panose="02040503050406030204" pitchFamily="18" charset="0"/>
                             </a:rPr>
@@ -7245,24 +7379,24 @@
                         </m:sSubPr>
                         <m:e>
                           <m:r>
-                            <a:rPr lang="en-US" b="0" i="1" smtClean="0">
+                            <a:rPr lang="en-GB" b="0" i="1" smtClean="0">
                               <a:solidFill>
-                                <a:schemeClr val="accent1"/>
+                                <a:srgbClr val="4909FF"/>
                               </a:solidFill>
                               <a:latin typeface="Cambria Math" panose="02040503050406030204" pitchFamily="18" charset="0"/>
                             </a:rPr>
-                            <m:t>𝛾</m:t>
+                            <m:t>𝑏</m:t>
                           </m:r>
                         </m:e>
                         <m:sub>
                           <m:r>
                             <a:rPr lang="en-US" b="0" i="1" smtClean="0">
                               <a:solidFill>
-                                <a:schemeClr val="accent1"/>
+                                <a:srgbClr val="4909FF"/>
                               </a:solidFill>
                               <a:latin typeface="Cambria Math" panose="02040503050406030204" pitchFamily="18" charset="0"/>
                             </a:rPr>
-                            <m:t>00</m:t>
+                            <m:t>0</m:t>
                           </m:r>
                         </m:sub>
                       </m:sSub>
@@ -7277,58 +7411,7 @@
                           <m:ctrlPr>
                             <a:rPr lang="en-US" b="0" i="1" smtClean="0">
                               <a:solidFill>
-                                <a:srgbClr val="FF0000"/>
-                              </a:solidFill>
-                              <a:latin typeface="Cambria Math" panose="02040503050406030204" pitchFamily="18" charset="0"/>
-                            </a:rPr>
-                          </m:ctrlPr>
-                        </m:sSubPr>
-                        <m:e>
-                          <m:r>
-                            <a:rPr lang="en-US" b="0" i="1" smtClean="0">
-                              <a:solidFill>
-                                <a:srgbClr val="FF0000"/>
-                              </a:solidFill>
-                              <a:latin typeface="Cambria Math" panose="02040503050406030204" pitchFamily="18" charset="0"/>
-                            </a:rPr>
-                            <m:t>𝜁</m:t>
-                          </m:r>
-                        </m:e>
-                        <m:sub>
-                          <m:r>
-                            <a:rPr lang="en-US" b="0" i="1" smtClean="0">
-                              <a:solidFill>
-                                <a:srgbClr val="FF0000"/>
-                              </a:solidFill>
-                              <a:latin typeface="Cambria Math" panose="02040503050406030204" pitchFamily="18" charset="0"/>
-                            </a:rPr>
-                            <m:t>0</m:t>
-                          </m:r>
-                          <m:r>
-                            <a:rPr lang="en-US" b="0" i="1" smtClean="0">
-                              <a:solidFill>
-                                <a:srgbClr val="FF0000"/>
-                              </a:solidFill>
-                              <a:latin typeface="Cambria Math" panose="02040503050406030204" pitchFamily="18" charset="0"/>
-                            </a:rPr>
-                            <m:t>𝑖</m:t>
-                          </m:r>
-                        </m:sub>
-                      </m:sSub>
-                      <m:r>
-                        <a:rPr lang="en-US" b="0" i="1" smtClean="0">
-                          <a:latin typeface="Cambria Math" panose="02040503050406030204" pitchFamily="18" charset="0"/>
-                        </a:rPr>
-                        <m:t>=</m:t>
-                      </m:r>
-                      <m:sSub>
-                        <m:sSubPr>
-                          <m:ctrlPr>
-                            <a:rPr lang="en-US" b="0" i="1" smtClean="0">
-                              <a:solidFill>
-                                <a:schemeClr val="accent6">
-                                  <a:lumMod val="75000"/>
-                                </a:schemeClr>
+                                <a:srgbClr val="FFC000"/>
                               </a:solidFill>
                               <a:latin typeface="Cambria Math" panose="02040503050406030204" pitchFamily="18" charset="0"/>
                             </a:rPr>
@@ -7338,22 +7421,18 @@
                           <m:r>
                             <a:rPr lang="en-GB" b="0" i="1" smtClean="0">
                               <a:solidFill>
-                                <a:schemeClr val="accent6">
-                                  <a:lumMod val="75000"/>
-                                </a:schemeClr>
+                                <a:srgbClr val="FFC000"/>
                               </a:solidFill>
                               <a:latin typeface="Cambria Math" panose="02040503050406030204" pitchFamily="18" charset="0"/>
                             </a:rPr>
-                            <m:t>𝑏</m:t>
+                            <m:t>𝑢</m:t>
                           </m:r>
                         </m:e>
                         <m:sub>
                           <m:r>
                             <a:rPr lang="en-US" b="0" i="1" smtClean="0">
                               <a:solidFill>
-                                <a:schemeClr val="accent6">
-                                  <a:lumMod val="75000"/>
-                                </a:schemeClr>
+                                <a:srgbClr val="FFC000"/>
                               </a:solidFill>
                               <a:latin typeface="Cambria Math" panose="02040503050406030204" pitchFamily="18" charset="0"/>
                             </a:rPr>
@@ -7362,9 +7441,7 @@
                           <m:r>
                             <a:rPr lang="en-US" b="0" i="1" smtClean="0">
                               <a:solidFill>
-                                <a:schemeClr val="accent6">
-                                  <a:lumMod val="75000"/>
-                                </a:schemeClr>
+                                <a:srgbClr val="FFC000"/>
                               </a:solidFill>
                               <a:latin typeface="Cambria Math" panose="02040503050406030204" pitchFamily="18" charset="0"/>
                             </a:rPr>
@@ -7372,10 +7449,23 @@
                           </m:r>
                         </m:sub>
                       </m:sSub>
+                      <m:r>
+                        <a:rPr lang="en-GB" b="0" i="0" smtClean="0">
+                          <a:solidFill>
+                            <a:srgbClr val="00B050"/>
+                          </a:solidFill>
+                          <a:latin typeface="Cambria Math" panose="02040503050406030204" pitchFamily="18" charset="0"/>
+                        </a:rPr>
+                        <m:t>)</m:t>
+                      </m:r>
                     </m:oMath>
                   </m:oMathPara>
                 </a14:m>
-                <a:endParaRPr lang="en-US" dirty="0"/>
+                <a:endParaRPr lang="en-US" dirty="0">
+                  <a:solidFill>
+                    <a:srgbClr val="FFC000"/>
+                  </a:solidFill>
+                </a:endParaRPr>
               </a:p>
             </p:txBody>
           </p:sp>
@@ -7397,14 +7487,14 @@
             </p:nvSpPr>
             <p:spPr>
               <a:xfrm>
-                <a:off x="1130432" y="3370459"/>
-                <a:ext cx="1692386" cy="369332"/>
+                <a:off x="1302921" y="3661386"/>
+                <a:ext cx="1236172" cy="369332"/>
               </a:xfrm>
               <a:prstGeom prst="rect">
                 <a:avLst/>
               </a:prstGeom>
               <a:blipFill>
-                <a:blip r:embed="rId5"/>
+                <a:blip r:embed="rId6"/>
                 <a:stretch>
                   <a:fillRect b="-13333"/>
                 </a:stretch>
@@ -7439,17 +7529,17 @@
         </p:nvCxnSpPr>
         <p:spPr>
           <a:xfrm>
-            <a:off x="6273527" y="2381691"/>
+            <a:off x="5299364" y="2782112"/>
             <a:ext cx="1236883" cy="0"/>
           </a:xfrm>
           <a:prstGeom prst="line">
             <a:avLst/>
           </a:prstGeom>
-          <a:ln w="38100">
+          <a:ln w="19050">
             <a:solidFill>
-              <a:schemeClr val="accent1"/>
+              <a:srgbClr val="4909FF"/>
             </a:solidFill>
-            <a:prstDash val="solid"/>
+            <a:prstDash val="sysDash"/>
           </a:ln>
         </p:spPr>
         <p:style>
@@ -7487,9 +7577,9 @@
           <a:prstGeom prst="rightBrace">
             <a:avLst/>
           </a:prstGeom>
-          <a:ln w="38100">
+          <a:ln w="28575">
             <a:solidFill>
-              <a:srgbClr val="FF0000"/>
+              <a:srgbClr val="FFC000"/>
             </a:solidFill>
           </a:ln>
         </p:spPr>
@@ -7512,7 +7602,11 @@
           <a:lstStyle/>
           <a:p>
             <a:pPr algn="ctr"/>
-            <a:endParaRPr lang="en-US"/>
+            <a:endParaRPr lang="en-US">
+              <a:solidFill>
+                <a:srgbClr val="FFC000"/>
+              </a:solidFill>
+            </a:endParaRPr>
           </a:p>
         </p:txBody>
       </p:sp>
@@ -7533,12 +7627,15 @@
             <p:spPr>
               <a:xfrm>
                 <a:off x="3120916" y="4028536"/>
-                <a:ext cx="505908" cy="369332"/>
+                <a:ext cx="543034" cy="369332"/>
               </a:xfrm>
               <a:prstGeom prst="rect">
                 <a:avLst/>
               </a:prstGeom>
               <a:noFill/>
+              <a:ln>
+                <a:noFill/>
+              </a:ln>
             </p:spPr>
             <p:txBody>
               <a:bodyPr wrap="none" rtlCol="0">
@@ -7558,7 +7655,7 @@
                           <m:ctrlPr>
                             <a:rPr lang="en-US" b="0" i="1" smtClean="0">
                               <a:solidFill>
-                                <a:srgbClr val="FF0000"/>
+                                <a:srgbClr val="FFC000"/>
                               </a:solidFill>
                               <a:latin typeface="Cambria Math" panose="02040503050406030204" pitchFamily="18" charset="0"/>
                             </a:rPr>
@@ -7566,20 +7663,20 @@
                         </m:sSubPr>
                         <m:e>
                           <m:r>
-                            <a:rPr lang="en-US" b="0" i="1" smtClean="0">
+                            <a:rPr lang="en-GB" b="0" i="1" smtClean="0">
                               <a:solidFill>
-                                <a:srgbClr val="FF0000"/>
+                                <a:srgbClr val="FFC000"/>
                               </a:solidFill>
                               <a:latin typeface="Cambria Math" panose="02040503050406030204" pitchFamily="18" charset="0"/>
                             </a:rPr>
-                            <m:t>𝜁</m:t>
+                            <m:t>𝑢</m:t>
                           </m:r>
                         </m:e>
                         <m:sub>
                           <m:r>
                             <a:rPr lang="en-US" b="0" i="1" smtClean="0">
                               <a:solidFill>
-                                <a:srgbClr val="FF0000"/>
+                                <a:srgbClr val="FFC000"/>
                               </a:solidFill>
                               <a:latin typeface="Cambria Math" panose="02040503050406030204" pitchFamily="18" charset="0"/>
                             </a:rPr>
@@ -7588,7 +7685,7 @@
                           <m:r>
                             <a:rPr lang="en-US" b="0" i="1" smtClean="0">
                               <a:solidFill>
-                                <a:srgbClr val="FF0000"/>
+                                <a:srgbClr val="FFC000"/>
                               </a:solidFill>
                               <a:latin typeface="Cambria Math" panose="02040503050406030204" pitchFamily="18" charset="0"/>
                             </a:rPr>
@@ -7601,7 +7698,7 @@
                 </a14:m>
                 <a:endParaRPr lang="en-US" dirty="0">
                   <a:solidFill>
-                    <a:srgbClr val="FF0000"/>
+                    <a:srgbClr val="FFC000"/>
                   </a:solidFill>
                 </a:endParaRPr>
               </a:p>
@@ -7626,17 +7723,20 @@
             <p:spPr>
               <a:xfrm>
                 <a:off x="3120916" y="4028536"/>
-                <a:ext cx="505908" cy="369332"/>
+                <a:ext cx="543034" cy="369332"/>
               </a:xfrm>
               <a:prstGeom prst="rect">
                 <a:avLst/>
               </a:prstGeom>
               <a:blipFill>
-                <a:blip r:embed="rId6"/>
+                <a:blip r:embed="rId7"/>
                 <a:stretch>
-                  <a:fillRect b="-13333"/>
+                  <a:fillRect b="-1667"/>
                 </a:stretch>
               </a:blipFill>
+              <a:ln>
+                <a:noFill/>
+              </a:ln>
             </p:spPr>
             <p:txBody>
               <a:bodyPr/>
@@ -7669,8 +7769,8 @@
             </p:nvSpPr>
             <p:spPr>
               <a:xfrm>
-                <a:off x="7541172" y="2080982"/>
-                <a:ext cx="551498" cy="369332"/>
+                <a:off x="6567009" y="2481403"/>
+                <a:ext cx="457305" cy="369332"/>
               </a:xfrm>
               <a:prstGeom prst="rect">
                 <a:avLst/>
@@ -7695,7 +7795,7 @@
                           <m:ctrlPr>
                             <a:rPr lang="en-US" b="0" i="1" smtClean="0">
                               <a:solidFill>
-                                <a:schemeClr val="accent1"/>
+                                <a:srgbClr val="4909FF"/>
                               </a:solidFill>
                               <a:latin typeface="Cambria Math" panose="02040503050406030204" pitchFamily="18" charset="0"/>
                             </a:rPr>
@@ -7703,31 +7803,35 @@
                         </m:sSubPr>
                         <m:e>
                           <m:r>
-                            <a:rPr lang="en-US" b="0" i="1" smtClean="0">
+                            <a:rPr lang="en-GB" b="0" i="1" smtClean="0">
                               <a:solidFill>
-                                <a:schemeClr val="accent1"/>
+                                <a:srgbClr val="4909FF"/>
                               </a:solidFill>
                               <a:latin typeface="Cambria Math" panose="02040503050406030204" pitchFamily="18" charset="0"/>
                             </a:rPr>
-                            <m:t>𝛾</m:t>
+                            <m:t>𝑏</m:t>
                           </m:r>
                         </m:e>
                         <m:sub>
                           <m:r>
                             <a:rPr lang="en-US" b="0" i="1" smtClean="0">
                               <a:solidFill>
-                                <a:schemeClr val="accent1"/>
+                                <a:srgbClr val="4909FF"/>
                               </a:solidFill>
                               <a:latin typeface="Cambria Math" panose="02040503050406030204" pitchFamily="18" charset="0"/>
                             </a:rPr>
-                            <m:t>10</m:t>
+                            <m:t>1</m:t>
                           </m:r>
                         </m:sub>
                       </m:sSub>
                     </m:oMath>
                   </m:oMathPara>
                 </a14:m>
-                <a:endParaRPr lang="en-US" dirty="0"/>
+                <a:endParaRPr lang="en-US" dirty="0">
+                  <a:solidFill>
+                    <a:srgbClr val="4909FF"/>
+                  </a:solidFill>
+                </a:endParaRPr>
               </a:p>
             </p:txBody>
           </p:sp>
@@ -7749,16 +7853,16 @@
             </p:nvSpPr>
             <p:spPr>
               <a:xfrm>
-                <a:off x="7541172" y="2080982"/>
-                <a:ext cx="551498" cy="369332"/>
+                <a:off x="6567009" y="2481403"/>
+                <a:ext cx="457305" cy="369332"/>
               </a:xfrm>
               <a:prstGeom prst="rect">
                 <a:avLst/>
               </a:prstGeom>
               <a:blipFill>
-                <a:blip r:embed="rId7"/>
+                <a:blip r:embed="rId8"/>
                 <a:stretch>
-                  <a:fillRect b="-3279"/>
+                  <a:fillRect/>
                 </a:stretch>
               </a:blipFill>
             </p:spPr>
@@ -7793,7 +7897,7 @@
         </p:nvCxnSpPr>
         <p:spPr>
           <a:xfrm>
-            <a:off x="7520921" y="2107317"/>
+            <a:off x="6546758" y="2507738"/>
             <a:ext cx="0" cy="284516"/>
           </a:xfrm>
           <a:prstGeom prst="line">
@@ -7801,7 +7905,7 @@
           </a:prstGeom>
           <a:ln w="38100">
             <a:solidFill>
-              <a:schemeClr val="accent1"/>
+              <a:srgbClr val="4909FF"/>
             </a:solidFill>
             <a:prstDash val="solid"/>
           </a:ln>
@@ -7837,7 +7941,7 @@
             </p:nvSpPr>
             <p:spPr>
               <a:xfrm>
-                <a:off x="6714366" y="2368974"/>
+                <a:off x="5740203" y="2769395"/>
                 <a:ext cx="365805" cy="369332"/>
               </a:xfrm>
               <a:prstGeom prst="rect">
@@ -7861,7 +7965,7 @@
                       <m:r>
                         <a:rPr lang="en-US" b="0" i="1" smtClean="0">
                           <a:solidFill>
-                            <a:schemeClr val="accent1"/>
+                            <a:srgbClr val="4909FF"/>
                           </a:solidFill>
                           <a:latin typeface="Cambria Math" panose="02040503050406030204" pitchFamily="18" charset="0"/>
                         </a:rPr>
@@ -7872,7 +7976,7 @@
                 </a14:m>
                 <a:endParaRPr lang="en-US" dirty="0">
                   <a:solidFill>
-                    <a:schemeClr val="accent1"/>
+                    <a:srgbClr val="4909FF"/>
                   </a:solidFill>
                 </a:endParaRPr>
               </a:p>
@@ -7896,14 +8000,14 @@
             </p:nvSpPr>
             <p:spPr>
               <a:xfrm>
-                <a:off x="6714366" y="2368974"/>
+                <a:off x="5740203" y="2769395"/>
                 <a:ext cx="365805" cy="369332"/>
               </a:xfrm>
               <a:prstGeom prst="rect">
                 <a:avLst/>
               </a:prstGeom>
               <a:blipFill>
-                <a:blip r:embed="rId8"/>
+                <a:blip r:embed="rId9"/>
                 <a:stretch>
                   <a:fillRect/>
                 </a:stretch>
@@ -7940,15 +8044,15 @@
         </p:nvCxnSpPr>
         <p:spPr>
           <a:xfrm>
-            <a:off x="7520921" y="1831976"/>
-            <a:ext cx="0" cy="275341"/>
+            <a:off x="6546758" y="2247129"/>
+            <a:ext cx="0" cy="260609"/>
           </a:xfrm>
           <a:prstGeom prst="line">
             <a:avLst/>
           </a:prstGeom>
           <a:ln w="38100">
             <a:solidFill>
-              <a:srgbClr val="FF0000"/>
+              <a:srgbClr val="FFC000"/>
             </a:solidFill>
           </a:ln>
         </p:spPr>
@@ -7967,139 +8071,6 @@
           </a:fontRef>
         </p:style>
       </p:cxnSp>
-      <mc:AlternateContent xmlns:mc="http://schemas.openxmlformats.org/markup-compatibility/2006">
-        <mc:Choice xmlns:a14="http://schemas.microsoft.com/office/drawing/2010/main" Requires="a14">
-          <p:sp>
-            <p:nvSpPr>
-              <p:cNvPr id="41" name="TextBox 40">
-                <a:extLst>
-                  <a:ext uri="{FF2B5EF4-FFF2-40B4-BE49-F238E27FC236}">
-                    <a16:creationId xmlns:a16="http://schemas.microsoft.com/office/drawing/2014/main" id="{B90E33FC-528F-FA49-A3FB-EE70D74C8BD9}"/>
-                  </a:ext>
-                </a:extLst>
-              </p:cNvPr>
-              <p:cNvSpPr txBox="1"/>
-              <p:nvPr/>
-            </p:nvSpPr>
-            <p:spPr>
-              <a:xfrm>
-                <a:off x="7566628" y="1772281"/>
-                <a:ext cx="500586" cy="369332"/>
-              </a:xfrm>
-              <a:prstGeom prst="rect">
-                <a:avLst/>
-              </a:prstGeom>
-              <a:noFill/>
-            </p:spPr>
-            <p:txBody>
-              <a:bodyPr wrap="none" rtlCol="0">
-                <a:spAutoFit/>
-              </a:bodyPr>
-              <a:lstStyle/>
-              <a:p>
-                <a:pPr/>
-                <a14:m>
-                  <m:oMathPara xmlns:m="http://schemas.openxmlformats.org/officeDocument/2006/math">
-                    <m:oMathParaPr>
-                      <m:jc m:val="centerGroup"/>
-                    </m:oMathParaPr>
-                    <m:oMath xmlns:m="http://schemas.openxmlformats.org/officeDocument/2006/math">
-                      <m:sSub>
-                        <m:sSubPr>
-                          <m:ctrlPr>
-                            <a:rPr lang="en-US" b="0" i="1" smtClean="0">
-                              <a:solidFill>
-                                <a:srgbClr val="FF0000"/>
-                              </a:solidFill>
-                              <a:latin typeface="Cambria Math" panose="02040503050406030204" pitchFamily="18" charset="0"/>
-                            </a:rPr>
-                          </m:ctrlPr>
-                        </m:sSubPr>
-                        <m:e>
-                          <m:r>
-                            <a:rPr lang="en-US" b="0" i="1" smtClean="0">
-                              <a:solidFill>
-                                <a:srgbClr val="FF0000"/>
-                              </a:solidFill>
-                              <a:latin typeface="Cambria Math" panose="02040503050406030204" pitchFamily="18" charset="0"/>
-                            </a:rPr>
-                            <m:t>𝜁</m:t>
-                          </m:r>
-                        </m:e>
-                        <m:sub>
-                          <m:r>
-                            <a:rPr lang="en-US" b="0" i="1" smtClean="0">
-                              <a:solidFill>
-                                <a:srgbClr val="FF0000"/>
-                              </a:solidFill>
-                              <a:latin typeface="Cambria Math" panose="02040503050406030204" pitchFamily="18" charset="0"/>
-                            </a:rPr>
-                            <m:t>1</m:t>
-                          </m:r>
-                          <m:r>
-                            <a:rPr lang="en-US" b="0" i="1" smtClean="0">
-                              <a:solidFill>
-                                <a:srgbClr val="FF0000"/>
-                              </a:solidFill>
-                              <a:latin typeface="Cambria Math" panose="02040503050406030204" pitchFamily="18" charset="0"/>
-                            </a:rPr>
-                            <m:t>𝑖</m:t>
-                          </m:r>
-                        </m:sub>
-                      </m:sSub>
-                    </m:oMath>
-                  </m:oMathPara>
-                </a14:m>
-                <a:endParaRPr lang="en-US" dirty="0"/>
-              </a:p>
-            </p:txBody>
-          </p:sp>
-        </mc:Choice>
-        <mc:Fallback>
-          <p:sp>
-            <p:nvSpPr>
-              <p:cNvPr id="41" name="TextBox 40">
-                <a:extLst>
-                  <a:ext uri="{FF2B5EF4-FFF2-40B4-BE49-F238E27FC236}">
-                    <a16:creationId xmlns:a16="http://schemas.microsoft.com/office/drawing/2014/main" id="{B90E33FC-528F-FA49-A3FB-EE70D74C8BD9}"/>
-                  </a:ext>
-                </a:extLst>
-              </p:cNvPr>
-              <p:cNvSpPr txBox="1">
-                <a:spLocks noRot="1" noChangeAspect="1" noMove="1" noResize="1" noEditPoints="1" noAdjustHandles="1" noChangeArrowheads="1" noChangeShapeType="1" noTextEdit="1"/>
-              </p:cNvSpPr>
-              <p:nvPr/>
-            </p:nvSpPr>
-            <p:spPr>
-              <a:xfrm>
-                <a:off x="7566628" y="1772281"/>
-                <a:ext cx="500586" cy="369332"/>
-              </a:xfrm>
-              <a:prstGeom prst="rect">
-                <a:avLst/>
-              </a:prstGeom>
-              <a:blipFill>
-                <a:blip r:embed="rId9"/>
-                <a:stretch>
-                  <a:fillRect b="-13333"/>
-                </a:stretch>
-              </a:blipFill>
-            </p:spPr>
-            <p:txBody>
-              <a:bodyPr/>
-              <a:lstStyle/>
-              <a:p>
-                <a:r>
-                  <a:rPr lang="en-GB">
-                    <a:noFill/>
-                  </a:rPr>
-                  <a:t> </a:t>
-                </a:r>
-              </a:p>
-            </p:txBody>
-          </p:sp>
-        </mc:Fallback>
-      </mc:AlternateContent>
       <p:sp>
         <p:nvSpPr>
           <p:cNvPr id="44" name="Right Brace 43">
@@ -8114,7 +8085,7 @@
         </p:nvSpPr>
         <p:spPr>
           <a:xfrm>
-            <a:off x="8165588" y="1772281"/>
+            <a:off x="7018113" y="2190630"/>
             <a:ext cx="253583" cy="619552"/>
           </a:xfrm>
           <a:prstGeom prst="rightBrace">
@@ -8165,8 +8136,8 @@
             </p:nvSpPr>
             <p:spPr>
               <a:xfrm>
-                <a:off x="8527766" y="1846708"/>
-                <a:ext cx="1676420" cy="369332"/>
+                <a:off x="8587197" y="2280148"/>
+                <a:ext cx="1225528" cy="369332"/>
               </a:xfrm>
               <a:prstGeom prst="rect">
                 <a:avLst/>
@@ -8186,12 +8157,21 @@
                       <m:jc m:val="centerGroup"/>
                     </m:oMathParaPr>
                     <m:oMath xmlns:m="http://schemas.openxmlformats.org/officeDocument/2006/math">
+                      <m:r>
+                        <a:rPr lang="en-GB" b="0" i="1" smtClean="0">
+                          <a:solidFill>
+                            <a:srgbClr val="00B050"/>
+                          </a:solidFill>
+                          <a:latin typeface="Cambria Math" panose="02040503050406030204" pitchFamily="18" charset="0"/>
+                        </a:rPr>
+                        <m:t>(</m:t>
+                      </m:r>
                       <m:sSub>
                         <m:sSubPr>
                           <m:ctrlPr>
                             <a:rPr lang="en-US" b="0" i="1" smtClean="0">
                               <a:solidFill>
-                                <a:schemeClr val="accent1"/>
+                                <a:srgbClr val="4909FF"/>
                               </a:solidFill>
                               <a:latin typeface="Cambria Math" panose="02040503050406030204" pitchFamily="18" charset="0"/>
                             </a:rPr>
@@ -8199,24 +8179,24 @@
                         </m:sSubPr>
                         <m:e>
                           <m:r>
-                            <a:rPr lang="en-US" b="0" i="1" smtClean="0">
+                            <a:rPr lang="en-GB" b="0" i="1" smtClean="0">
                               <a:solidFill>
-                                <a:schemeClr val="accent1"/>
+                                <a:srgbClr val="4909FF"/>
                               </a:solidFill>
                               <a:latin typeface="Cambria Math" panose="02040503050406030204" pitchFamily="18" charset="0"/>
                             </a:rPr>
-                            <m:t>𝛾</m:t>
+                            <m:t>𝑏</m:t>
                           </m:r>
                         </m:e>
                         <m:sub>
                           <m:r>
                             <a:rPr lang="en-US" b="0" i="1" smtClean="0">
                               <a:solidFill>
-                                <a:schemeClr val="accent1"/>
+                                <a:srgbClr val="4909FF"/>
                               </a:solidFill>
                               <a:latin typeface="Cambria Math" panose="02040503050406030204" pitchFamily="18" charset="0"/>
                             </a:rPr>
-                            <m:t>10</m:t>
+                            <m:t>1</m:t>
                           </m:r>
                         </m:sub>
                       </m:sSub>
@@ -8231,58 +8211,7 @@
                           <m:ctrlPr>
                             <a:rPr lang="en-US" b="0" i="1" smtClean="0">
                               <a:solidFill>
-                                <a:srgbClr val="FF0000"/>
-                              </a:solidFill>
-                              <a:latin typeface="Cambria Math" panose="02040503050406030204" pitchFamily="18" charset="0"/>
-                            </a:rPr>
-                          </m:ctrlPr>
-                        </m:sSubPr>
-                        <m:e>
-                          <m:r>
-                            <a:rPr lang="en-US" b="0" i="1" smtClean="0">
-                              <a:solidFill>
-                                <a:srgbClr val="FF0000"/>
-                              </a:solidFill>
-                              <a:latin typeface="Cambria Math" panose="02040503050406030204" pitchFamily="18" charset="0"/>
-                            </a:rPr>
-                            <m:t>𝜁</m:t>
-                          </m:r>
-                        </m:e>
-                        <m:sub>
-                          <m:r>
-                            <a:rPr lang="en-US" b="0" i="1" smtClean="0">
-                              <a:solidFill>
-                                <a:srgbClr val="FF0000"/>
-                              </a:solidFill>
-                              <a:latin typeface="Cambria Math" panose="02040503050406030204" pitchFamily="18" charset="0"/>
-                            </a:rPr>
-                            <m:t>1</m:t>
-                          </m:r>
-                          <m:r>
-                            <a:rPr lang="en-US" b="0" i="1" smtClean="0">
-                              <a:solidFill>
-                                <a:srgbClr val="FF0000"/>
-                              </a:solidFill>
-                              <a:latin typeface="Cambria Math" panose="02040503050406030204" pitchFamily="18" charset="0"/>
-                            </a:rPr>
-                            <m:t>𝑖</m:t>
-                          </m:r>
-                        </m:sub>
-                      </m:sSub>
-                      <m:r>
-                        <a:rPr lang="en-US" b="0" i="1" smtClean="0">
-                          <a:latin typeface="Cambria Math" panose="02040503050406030204" pitchFamily="18" charset="0"/>
-                        </a:rPr>
-                        <m:t>=</m:t>
-                      </m:r>
-                      <m:sSub>
-                        <m:sSubPr>
-                          <m:ctrlPr>
-                            <a:rPr lang="en-US" b="0" i="1" smtClean="0">
-                              <a:solidFill>
-                                <a:schemeClr val="accent6">
-                                  <a:lumMod val="75000"/>
-                                </a:schemeClr>
+                                <a:srgbClr val="FFC000"/>
                               </a:solidFill>
                               <a:latin typeface="Cambria Math" panose="02040503050406030204" pitchFamily="18" charset="0"/>
                             </a:rPr>
@@ -8292,22 +8221,18 @@
                           <m:r>
                             <a:rPr lang="en-GB" b="0" i="1" smtClean="0">
                               <a:solidFill>
-                                <a:schemeClr val="accent6">
-                                  <a:lumMod val="75000"/>
-                                </a:schemeClr>
+                                <a:srgbClr val="FFC000"/>
                               </a:solidFill>
                               <a:latin typeface="Cambria Math" panose="02040503050406030204" pitchFamily="18" charset="0"/>
                             </a:rPr>
-                            <m:t>𝑏</m:t>
+                            <m:t>𝑢</m:t>
                           </m:r>
                         </m:e>
                         <m:sub>
                           <m:r>
                             <a:rPr lang="en-US" b="0" i="1" smtClean="0">
                               <a:solidFill>
-                                <a:schemeClr val="accent6">
-                                  <a:lumMod val="75000"/>
-                                </a:schemeClr>
+                                <a:srgbClr val="FFC000"/>
                               </a:solidFill>
                               <a:latin typeface="Cambria Math" panose="02040503050406030204" pitchFamily="18" charset="0"/>
                             </a:rPr>
@@ -8316,9 +8241,7 @@
                           <m:r>
                             <a:rPr lang="en-US" b="0" i="1" smtClean="0">
                               <a:solidFill>
-                                <a:schemeClr val="accent6">
-                                  <a:lumMod val="75000"/>
-                                </a:schemeClr>
+                                <a:srgbClr val="FFC000"/>
                               </a:solidFill>
                               <a:latin typeface="Cambria Math" panose="02040503050406030204" pitchFamily="18" charset="0"/>
                             </a:rPr>
@@ -8326,6 +8249,15 @@
                           </m:r>
                         </m:sub>
                       </m:sSub>
+                      <m:r>
+                        <a:rPr lang="en-GB" b="0" i="1" smtClean="0">
+                          <a:solidFill>
+                            <a:srgbClr val="00B050"/>
+                          </a:solidFill>
+                          <a:latin typeface="Cambria Math" panose="02040503050406030204" pitchFamily="18" charset="0"/>
+                        </a:rPr>
+                        <m:t>)</m:t>
+                      </m:r>
                     </m:oMath>
                   </m:oMathPara>
                 </a14:m>
@@ -8351,8 +8283,8 @@
             </p:nvSpPr>
             <p:spPr>
               <a:xfrm>
-                <a:off x="8527766" y="1846708"/>
-                <a:ext cx="1676420" cy="369332"/>
+                <a:off x="8587197" y="2280148"/>
+                <a:ext cx="1225528" cy="369332"/>
               </a:xfrm>
               <a:prstGeom prst="rect">
                 <a:avLst/>
@@ -8360,7 +8292,7 @@
               <a:blipFill>
                 <a:blip r:embed="rId10"/>
                 <a:stretch>
-                  <a:fillRect b="-11475"/>
+                  <a:fillRect b="-13115"/>
                 </a:stretch>
               </a:blipFill>
             </p:spPr>
@@ -8395,7 +8327,7 @@
             </p:nvSpPr>
             <p:spPr>
               <a:xfrm>
-                <a:off x="9197490" y="943613"/>
+                <a:off x="8928196" y="1048637"/>
                 <a:ext cx="1265475" cy="369332"/>
               </a:xfrm>
               <a:prstGeom prst="rect">
@@ -8412,9 +8344,7 @@
                 <a:r>
                   <a:rPr lang="en-US" dirty="0">
                     <a:solidFill>
-                      <a:schemeClr val="accent6">
-                        <a:lumMod val="75000"/>
-                      </a:schemeClr>
+                      <a:srgbClr val="00B050"/>
                     </a:solidFill>
                   </a:rPr>
                   <a:t>group </a:t>
@@ -8424,9 +8354,7 @@
                     <m:r>
                       <a:rPr lang="en-US" b="0" i="1" smtClean="0">
                         <a:solidFill>
-                          <a:schemeClr val="accent6">
-                            <a:lumMod val="75000"/>
-                          </a:schemeClr>
+                          <a:srgbClr val="00B050"/>
                         </a:solidFill>
                         <a:latin typeface="Cambria Math" panose="02040503050406030204" pitchFamily="18" charset="0"/>
                       </a:rPr>
@@ -8437,9 +8365,7 @@
                 <a:r>
                   <a:rPr lang="en-US" dirty="0">
                     <a:solidFill>
-                      <a:schemeClr val="accent6">
-                        <a:lumMod val="75000"/>
-                      </a:schemeClr>
+                      <a:srgbClr val="00B050"/>
                     </a:solidFill>
                   </a:rPr>
                   <a:t> line</a:t>
@@ -8465,7 +8391,7 @@
             </p:nvSpPr>
             <p:spPr>
               <a:xfrm>
-                <a:off x="9197490" y="943613"/>
+                <a:off x="8928196" y="1048637"/>
                 <a:ext cx="1265475" cy="369332"/>
               </a:xfrm>
               <a:prstGeom prst="rect">
@@ -8474,7 +8400,7 @@
               <a:blipFill>
                 <a:blip r:embed="rId11"/>
                 <a:stretch>
-                  <a:fillRect l="-4348" t="-10000" r="-3865" b="-26667"/>
+                  <a:fillRect l="-4348" t="-8197" r="-3865" b="-24590"/>
                 </a:stretch>
               </a:blipFill>
             </p:spPr>
@@ -8517,8 +8443,9 @@
           </a:prstGeom>
           <a:ln w="38100">
             <a:solidFill>
-              <a:srgbClr val="FF0000"/>
+              <a:schemeClr val="tx1"/>
             </a:solidFill>
+            <a:prstDash val="sysDot"/>
           </a:ln>
         </p:spPr>
         <p:style>
@@ -8578,7 +8505,7 @@
                           <m:ctrlPr>
                             <a:rPr lang="en-US" b="0" i="1" smtClean="0">
                               <a:solidFill>
-                                <a:srgbClr val="FF0000"/>
+                                <a:schemeClr val="tx1"/>
                               </a:solidFill>
                               <a:latin typeface="Cambria Math" panose="02040503050406030204" pitchFamily="18" charset="0"/>
                             </a:rPr>
@@ -8588,7 +8515,7 @@
                           <m:r>
                             <a:rPr lang="en-US" b="0" i="1" smtClean="0">
                               <a:solidFill>
-                                <a:srgbClr val="FF0000"/>
+                                <a:schemeClr val="tx1"/>
                               </a:solidFill>
                               <a:latin typeface="Cambria Math" panose="02040503050406030204" pitchFamily="18" charset="0"/>
                             </a:rPr>
@@ -8599,7 +8526,7 @@
                           <m:r>
                             <a:rPr lang="en-US" b="0" i="1" smtClean="0">
                               <a:solidFill>
-                                <a:srgbClr val="FF0000"/>
+                                <a:schemeClr val="tx1"/>
                               </a:solidFill>
                               <a:latin typeface="Cambria Math" panose="02040503050406030204" pitchFamily="18" charset="0"/>
                             </a:rPr>
@@ -8610,7 +8537,11 @@
                     </m:oMath>
                   </m:oMathPara>
                 </a14:m>
-                <a:endParaRPr lang="en-US" dirty="0"/>
+                <a:endParaRPr lang="en-US" dirty="0">
+                  <a:solidFill>
+                    <a:schemeClr val="tx1"/>
+                  </a:solidFill>
+                </a:endParaRPr>
               </a:p>
             </p:txBody>
           </p:sp>
@@ -8676,13 +8607,16 @@
             </p:nvSpPr>
             <p:spPr>
               <a:xfrm>
-                <a:off x="939655" y="3047266"/>
+                <a:off x="1092830" y="3406513"/>
                 <a:ext cx="1772601" cy="369332"/>
               </a:xfrm>
               <a:prstGeom prst="rect">
                 <a:avLst/>
               </a:prstGeom>
               <a:noFill/>
+              <a:ln>
+                <a:noFill/>
+              </a:ln>
             </p:spPr>
             <p:txBody>
               <a:bodyPr wrap="none" rtlCol="0">
@@ -8693,9 +8627,7 @@
                 <a:r>
                   <a:rPr lang="en-US" dirty="0">
                     <a:solidFill>
-                      <a:schemeClr val="accent6">
-                        <a:lumMod val="75000"/>
-                      </a:schemeClr>
+                      <a:srgbClr val="00B050"/>
                     </a:solidFill>
                   </a:rPr>
                   <a:t>group </a:t>
@@ -8705,9 +8637,7 @@
                     <m:r>
                       <a:rPr lang="en-US" b="0" i="1" smtClean="0">
                         <a:solidFill>
-                          <a:schemeClr val="accent6">
-                            <a:lumMod val="75000"/>
-                          </a:schemeClr>
+                          <a:srgbClr val="00B050"/>
                         </a:solidFill>
                         <a:latin typeface="Cambria Math" panose="02040503050406030204" pitchFamily="18" charset="0"/>
                       </a:rPr>
@@ -8718,9 +8648,7 @@
                 <a:r>
                   <a:rPr lang="en-US" dirty="0">
                     <a:solidFill>
-                      <a:schemeClr val="accent6">
-                        <a:lumMod val="75000"/>
-                      </a:schemeClr>
+                      <a:srgbClr val="00B050"/>
                     </a:solidFill>
                   </a:rPr>
                   <a:t> intercept</a:t>
@@ -8746,7 +8674,7 @@
             </p:nvSpPr>
             <p:spPr>
               <a:xfrm>
-                <a:off x="939655" y="3047266"/>
+                <a:off x="1092830" y="3406513"/>
                 <a:ext cx="1772601" cy="369332"/>
               </a:xfrm>
               <a:prstGeom prst="rect">
@@ -8758,6 +8686,9 @@
                   <a:fillRect l="-2749" t="-10000" r="-3093" b="-26667"/>
                 </a:stretch>
               </a:blipFill>
+              <a:ln>
+                <a:noFill/>
+              </a:ln>
             </p:spPr>
             <p:txBody>
               <a:bodyPr/>
@@ -8790,8 +8721,8 @@
             </p:nvSpPr>
             <p:spPr>
               <a:xfrm>
-                <a:off x="10118033" y="1831976"/>
-                <a:ext cx="1592487" cy="369332"/>
+                <a:off x="7271696" y="2277572"/>
+                <a:ext cx="1424172" cy="369332"/>
               </a:xfrm>
               <a:prstGeom prst="rect">
                 <a:avLst/>
@@ -8807,21 +8738,17 @@
                 <a:r>
                   <a:rPr lang="en-US" dirty="0">
                     <a:solidFill>
-                      <a:schemeClr val="accent6">
-                        <a:lumMod val="75000"/>
-                      </a:schemeClr>
+                      <a:srgbClr val="00B050"/>
                     </a:solidFill>
                   </a:rPr>
-                  <a:t>= group </a:t>
+                  <a:t>group </a:t>
                 </a:r>
                 <a14:m>
                   <m:oMath xmlns:m="http://schemas.openxmlformats.org/officeDocument/2006/math">
                     <m:r>
                       <a:rPr lang="en-US" b="0" i="1" smtClean="0">
                         <a:solidFill>
-                          <a:schemeClr val="accent6">
-                            <a:lumMod val="75000"/>
-                          </a:schemeClr>
+                          <a:srgbClr val="00B050"/>
                         </a:solidFill>
                         <a:latin typeface="Cambria Math" panose="02040503050406030204" pitchFamily="18" charset="0"/>
                       </a:rPr>
@@ -8832,9 +8759,7 @@
                 <a:r>
                   <a:rPr lang="en-US" dirty="0">
                     <a:solidFill>
-                      <a:schemeClr val="accent6">
-                        <a:lumMod val="75000"/>
-                      </a:schemeClr>
+                      <a:srgbClr val="00B050"/>
                     </a:solidFill>
                   </a:rPr>
                   <a:t> slope</a:t>
@@ -8860,8 +8785,8 @@
             </p:nvSpPr>
             <p:spPr>
               <a:xfrm>
-                <a:off x="10118033" y="1831976"/>
-                <a:ext cx="1592487" cy="369332"/>
+                <a:off x="7271696" y="2277572"/>
+                <a:ext cx="1424172" cy="369332"/>
               </a:xfrm>
               <a:prstGeom prst="rect">
                 <a:avLst/>
@@ -8869,7 +8794,7 @@
               <a:blipFill>
                 <a:blip r:embed="rId14"/>
                 <a:stretch>
-                  <a:fillRect l="-3448" t="-10000" r="-2682" b="-26667"/>
+                  <a:fillRect l="-3863" t="-10000" r="-3433" b="-26667"/>
                 </a:stretch>
               </a:blipFill>
             </p:spPr>
@@ -8902,8 +8827,8 @@
         </p:nvSpPr>
         <p:spPr>
           <a:xfrm>
-            <a:off x="3568085" y="2244708"/>
-            <a:ext cx="1139223" cy="369332"/>
+            <a:off x="3630838" y="2244708"/>
+            <a:ext cx="1095364" cy="369332"/>
           </a:xfrm>
           <a:prstGeom prst="rect">
             <a:avLst/>
@@ -8917,12 +8842,8 @@
           <a:lstStyle/>
           <a:p>
             <a:r>
-              <a:rPr lang="en-US" dirty="0">
-                <a:solidFill>
-                  <a:srgbClr val="FF0000"/>
-                </a:solidFill>
-              </a:rPr>
-              <a:t>Residual =</a:t>
+              <a:rPr lang="en-US" dirty="0"/>
+              <a:t>residual =</a:t>
             </a:r>
           </a:p>
         </p:txBody>
@@ -8941,8 +8862,8 @@
         </p:nvSpPr>
         <p:spPr>
           <a:xfrm>
-            <a:off x="3302560" y="4749942"/>
-            <a:ext cx="1886029" cy="369332"/>
+            <a:off x="1147783" y="4447338"/>
+            <a:ext cx="1717714" cy="369332"/>
           </a:xfrm>
           <a:prstGeom prst="rect">
             <a:avLst/>
@@ -8958,10 +8879,10 @@
             <a:r>
               <a:rPr lang="en-US" dirty="0">
                 <a:solidFill>
-                  <a:schemeClr val="accent1"/>
+                  <a:srgbClr val="4909FF"/>
                 </a:solidFill>
               </a:rPr>
-              <a:t>= overall intercept</a:t>
+              <a:t>overall intercept</a:t>
             </a:r>
           </a:p>
         </p:txBody>
@@ -8980,7 +8901,7 @@
         </p:nvSpPr>
         <p:spPr>
           <a:xfrm>
-            <a:off x="8063106" y="3681982"/>
+            <a:off x="6981365" y="3912078"/>
             <a:ext cx="1537600" cy="369332"/>
           </a:xfrm>
           <a:prstGeom prst="rect">
@@ -8997,7 +8918,7 @@
             <a:r>
               <a:rPr lang="en-US" dirty="0">
                 <a:solidFill>
-                  <a:schemeClr val="accent1"/>
+                  <a:srgbClr val="4909FF"/>
                 </a:solidFill>
               </a:rPr>
               <a:t>= overall slope</a:t>
@@ -9005,6 +8926,324 @@
           </a:p>
         </p:txBody>
       </p:sp>
+      <p:sp>
+        <p:nvSpPr>
+          <p:cNvPr id="50" name="TextBox 49">
+            <a:extLst>
+              <a:ext uri="{FF2B5EF4-FFF2-40B4-BE49-F238E27FC236}">
+                <a16:creationId xmlns:a16="http://schemas.microsoft.com/office/drawing/2014/main" id="{436EBDF8-6931-4737-A400-B609FA6CB975}"/>
+              </a:ext>
+            </a:extLst>
+          </p:cNvPr>
+          <p:cNvSpPr txBox="1"/>
+          <p:nvPr/>
+        </p:nvSpPr>
+        <p:spPr>
+          <a:xfrm>
+            <a:off x="2698418" y="4557840"/>
+            <a:ext cx="295274" cy="400110"/>
+          </a:xfrm>
+          <a:prstGeom prst="rect">
+            <a:avLst/>
+          </a:prstGeom>
+          <a:noFill/>
+        </p:spPr>
+        <p:txBody>
+          <a:bodyPr wrap="none" rtlCol="0">
+            <a:spAutoFit/>
+          </a:bodyPr>
+          <a:lstStyle/>
+          <a:p>
+            <a:r>
+              <a:rPr lang="en-US" sz="2000" dirty="0">
+                <a:solidFill>
+                  <a:srgbClr val="4909FF"/>
+                </a:solidFill>
+              </a:rPr>
+              <a:t>x</a:t>
+            </a:r>
+          </a:p>
+        </p:txBody>
+      </p:sp>
+      <p:sp>
+        <p:nvSpPr>
+          <p:cNvPr id="51" name="TextBox 50">
+            <a:extLst>
+              <a:ext uri="{FF2B5EF4-FFF2-40B4-BE49-F238E27FC236}">
+                <a16:creationId xmlns:a16="http://schemas.microsoft.com/office/drawing/2014/main" id="{B9B230D5-05E0-4862-AF4A-C332601F1D8D}"/>
+              </a:ext>
+            </a:extLst>
+          </p:cNvPr>
+          <p:cNvSpPr txBox="1"/>
+          <p:nvPr/>
+        </p:nvSpPr>
+        <p:spPr>
+          <a:xfrm>
+            <a:off x="2701019" y="3515873"/>
+            <a:ext cx="295274" cy="400110"/>
+          </a:xfrm>
+          <a:prstGeom prst="rect">
+            <a:avLst/>
+          </a:prstGeom>
+          <a:noFill/>
+        </p:spPr>
+        <p:txBody>
+          <a:bodyPr wrap="none" rtlCol="0">
+            <a:spAutoFit/>
+          </a:bodyPr>
+          <a:lstStyle/>
+          <a:p>
+            <a:r>
+              <a:rPr lang="en-US" sz="2000" dirty="0">
+                <a:solidFill>
+                  <a:srgbClr val="00B050"/>
+                </a:solidFill>
+              </a:rPr>
+              <a:t>x</a:t>
+            </a:r>
+          </a:p>
+        </p:txBody>
+      </p:sp>
+      <p:sp>
+        <p:nvSpPr>
+          <p:cNvPr id="17" name="TextBox 16">
+            <a:extLst>
+              <a:ext uri="{FF2B5EF4-FFF2-40B4-BE49-F238E27FC236}">
+                <a16:creationId xmlns:a16="http://schemas.microsoft.com/office/drawing/2014/main" id="{945057EA-698B-4D31-A3C7-D846765E1F39}"/>
+              </a:ext>
+            </a:extLst>
+          </p:cNvPr>
+          <p:cNvSpPr txBox="1"/>
+          <p:nvPr/>
+        </p:nvSpPr>
+        <p:spPr>
+          <a:xfrm>
+            <a:off x="2714654" y="5597679"/>
+            <a:ext cx="301686" cy="369332"/>
+          </a:xfrm>
+          <a:prstGeom prst="rect">
+            <a:avLst/>
+          </a:prstGeom>
+          <a:noFill/>
+        </p:spPr>
+        <p:txBody>
+          <a:bodyPr wrap="none" rtlCol="0">
+            <a:spAutoFit/>
+          </a:bodyPr>
+          <a:lstStyle/>
+          <a:p>
+            <a:r>
+              <a:rPr lang="en-GB" dirty="0"/>
+              <a:t>0</a:t>
+            </a:r>
+          </a:p>
+        </p:txBody>
+      </p:sp>
+      <p:cxnSp>
+        <p:nvCxnSpPr>
+          <p:cNvPr id="19" name="Straight Connector 18">
+            <a:extLst>
+              <a:ext uri="{FF2B5EF4-FFF2-40B4-BE49-F238E27FC236}">
+                <a16:creationId xmlns:a16="http://schemas.microsoft.com/office/drawing/2014/main" id="{C7B9B707-B3E9-4BC3-86B6-8E8BC4C7159D}"/>
+              </a:ext>
+            </a:extLst>
+          </p:cNvPr>
+          <p:cNvCxnSpPr/>
+          <p:nvPr/>
+        </p:nvCxnSpPr>
+        <p:spPr>
+          <a:xfrm>
+            <a:off x="4090584" y="5587507"/>
+            <a:ext cx="0" cy="118229"/>
+          </a:xfrm>
+          <a:prstGeom prst="line">
+            <a:avLst/>
+          </a:prstGeom>
+          <a:ln w="28575">
+            <a:solidFill>
+              <a:schemeClr val="tx1"/>
+            </a:solidFill>
+          </a:ln>
+        </p:spPr>
+        <p:style>
+          <a:lnRef idx="1">
+            <a:schemeClr val="accent1"/>
+          </a:lnRef>
+          <a:fillRef idx="0">
+            <a:schemeClr val="accent1"/>
+          </a:fillRef>
+          <a:effectRef idx="0">
+            <a:schemeClr val="accent1"/>
+          </a:effectRef>
+          <a:fontRef idx="minor">
+            <a:schemeClr val="tx1"/>
+          </a:fontRef>
+        </p:style>
+      </p:cxnSp>
+      <p:cxnSp>
+        <p:nvCxnSpPr>
+          <p:cNvPr id="61" name="Straight Connector 60">
+            <a:extLst>
+              <a:ext uri="{FF2B5EF4-FFF2-40B4-BE49-F238E27FC236}">
+                <a16:creationId xmlns:a16="http://schemas.microsoft.com/office/drawing/2014/main" id="{34175B7D-9FD8-4B6A-8363-27D62C866807}"/>
+              </a:ext>
+            </a:extLst>
+          </p:cNvPr>
+          <p:cNvCxnSpPr/>
+          <p:nvPr/>
+        </p:nvCxnSpPr>
+        <p:spPr>
+          <a:xfrm>
+            <a:off x="5344643" y="5587507"/>
+            <a:ext cx="0" cy="118229"/>
+          </a:xfrm>
+          <a:prstGeom prst="line">
+            <a:avLst/>
+          </a:prstGeom>
+          <a:ln w="28575">
+            <a:solidFill>
+              <a:schemeClr val="tx1"/>
+            </a:solidFill>
+          </a:ln>
+        </p:spPr>
+        <p:style>
+          <a:lnRef idx="1">
+            <a:schemeClr val="accent1"/>
+          </a:lnRef>
+          <a:fillRef idx="0">
+            <a:schemeClr val="accent1"/>
+          </a:fillRef>
+          <a:effectRef idx="0">
+            <a:schemeClr val="accent1"/>
+          </a:effectRef>
+          <a:fontRef idx="minor">
+            <a:schemeClr val="tx1"/>
+          </a:fontRef>
+        </p:style>
+      </p:cxnSp>
+      <p:cxnSp>
+        <p:nvCxnSpPr>
+          <p:cNvPr id="63" name="Straight Connector 62">
+            <a:extLst>
+              <a:ext uri="{FF2B5EF4-FFF2-40B4-BE49-F238E27FC236}">
+                <a16:creationId xmlns:a16="http://schemas.microsoft.com/office/drawing/2014/main" id="{4C16F2EC-F3BD-4372-9D99-65F03E860EDA}"/>
+              </a:ext>
+            </a:extLst>
+          </p:cNvPr>
+          <p:cNvCxnSpPr/>
+          <p:nvPr/>
+        </p:nvCxnSpPr>
+        <p:spPr>
+          <a:xfrm>
+            <a:off x="6581526" y="5587507"/>
+            <a:ext cx="0" cy="118229"/>
+          </a:xfrm>
+          <a:prstGeom prst="line">
+            <a:avLst/>
+          </a:prstGeom>
+          <a:ln w="28575">
+            <a:solidFill>
+              <a:schemeClr val="tx1"/>
+            </a:solidFill>
+          </a:ln>
+        </p:spPr>
+        <p:style>
+          <a:lnRef idx="1">
+            <a:schemeClr val="accent1"/>
+          </a:lnRef>
+          <a:fillRef idx="0">
+            <a:schemeClr val="accent1"/>
+          </a:fillRef>
+          <a:effectRef idx="0">
+            <a:schemeClr val="accent1"/>
+          </a:effectRef>
+          <a:fontRef idx="minor">
+            <a:schemeClr val="tx1"/>
+          </a:fontRef>
+        </p:style>
+      </p:cxnSp>
+      <p:cxnSp>
+        <p:nvCxnSpPr>
+          <p:cNvPr id="65" name="Straight Connector 64">
+            <a:extLst>
+              <a:ext uri="{FF2B5EF4-FFF2-40B4-BE49-F238E27FC236}">
+                <a16:creationId xmlns:a16="http://schemas.microsoft.com/office/drawing/2014/main" id="{4370AE08-02CF-492F-816C-306E29F2B9C9}"/>
+              </a:ext>
+            </a:extLst>
+          </p:cNvPr>
+          <p:cNvCxnSpPr/>
+          <p:nvPr/>
+        </p:nvCxnSpPr>
+        <p:spPr>
+          <a:xfrm>
+            <a:off x="7818409" y="5587507"/>
+            <a:ext cx="0" cy="118229"/>
+          </a:xfrm>
+          <a:prstGeom prst="line">
+            <a:avLst/>
+          </a:prstGeom>
+          <a:ln w="28575">
+            <a:solidFill>
+              <a:schemeClr val="tx1"/>
+            </a:solidFill>
+          </a:ln>
+        </p:spPr>
+        <p:style>
+          <a:lnRef idx="1">
+            <a:schemeClr val="accent1"/>
+          </a:lnRef>
+          <a:fillRef idx="0">
+            <a:schemeClr val="accent1"/>
+          </a:fillRef>
+          <a:effectRef idx="0">
+            <a:schemeClr val="accent1"/>
+          </a:effectRef>
+          <a:fontRef idx="minor">
+            <a:schemeClr val="tx1"/>
+          </a:fontRef>
+        </p:style>
+      </p:cxnSp>
+      <p:cxnSp>
+        <p:nvCxnSpPr>
+          <p:cNvPr id="67" name="Straight Connector 66">
+            <a:extLst>
+              <a:ext uri="{FF2B5EF4-FFF2-40B4-BE49-F238E27FC236}">
+                <a16:creationId xmlns:a16="http://schemas.microsoft.com/office/drawing/2014/main" id="{C4AF1E59-4CEA-4E24-9AA1-5844D059F4CE}"/>
+              </a:ext>
+            </a:extLst>
+          </p:cNvPr>
+          <p:cNvCxnSpPr/>
+          <p:nvPr/>
+        </p:nvCxnSpPr>
+        <p:spPr>
+          <a:xfrm>
+            <a:off x="9055292" y="5590728"/>
+            <a:ext cx="0" cy="118229"/>
+          </a:xfrm>
+          <a:prstGeom prst="line">
+            <a:avLst/>
+          </a:prstGeom>
+          <a:ln w="28575">
+            <a:solidFill>
+              <a:schemeClr val="tx1"/>
+            </a:solidFill>
+          </a:ln>
+        </p:spPr>
+        <p:style>
+          <a:lnRef idx="1">
+            <a:schemeClr val="accent1"/>
+          </a:lnRef>
+          <a:fillRef idx="0">
+            <a:schemeClr val="accent1"/>
+          </a:fillRef>
+          <a:effectRef idx="0">
+            <a:schemeClr val="accent1"/>
+          </a:effectRef>
+          <a:fontRef idx="minor">
+            <a:schemeClr val="tx1"/>
+          </a:fontRef>
+        </p:style>
+      </p:cxnSp>
     </p:spTree>
     <p:extLst>
       <p:ext uri="{BB962C8B-B14F-4D97-AF65-F5344CB8AC3E}">

</xml_diff>